<commit_message>
v1.3.2: compact, centred executive summaries; profile adjusted on human feedback
Co-Authored-By: Claude Opus 5.5 <noreply@anthropic.com>
Claude-Session: https://claude.ai/code/session_01Rvc9GtWhuPc2Bv8Fiv99q3
</commit_message>
<xml_diff>
--- a/examples/gallery/output/deck.pptx
+++ b/examples/gallery/output/deck.pptx
@@ -24460,8 +24460,8 @@
         </p:nvSpPr>
         <p:spPr>
           <a:xfrm>
-            <a:off x="502920" y="1517904"/>
-            <a:ext cx="1325880" cy="1408176"/>
+            <a:off x="502920" y="2345527"/>
+            <a:ext cx="1325880" cy="704088"/>
           </a:xfrm>
           <a:prstGeom prst="rect">
             <a:avLst/>
@@ -24499,8 +24499,8 @@
         </p:nvSpPr>
         <p:spPr>
           <a:xfrm>
-            <a:off x="1920240" y="1517904"/>
-            <a:ext cx="3874185" cy="1408176"/>
+            <a:off x="1920240" y="2345527"/>
+            <a:ext cx="3874185" cy="704088"/>
           </a:xfrm>
           <a:prstGeom prst="rect">
             <a:avLst/>
@@ -24538,8 +24538,8 @@
         </p:nvSpPr>
         <p:spPr>
           <a:xfrm>
-            <a:off x="6023025" y="1517904"/>
-            <a:ext cx="5665750" cy="1408176"/>
+            <a:off x="6023025" y="2345527"/>
+            <a:ext cx="5665750" cy="704088"/>
           </a:xfrm>
           <a:prstGeom prst="rect">
             <a:avLst/>
@@ -24577,7 +24577,7 @@
         </p:nvCxnSpPr>
         <p:spPr>
           <a:xfrm>
-            <a:off x="502920" y="3031236"/>
+            <a:off x="502920" y="3154771"/>
             <a:ext cx="11185855" cy="0"/>
           </a:xfrm>
           <a:prstGeom prst="line">
@@ -24598,8 +24598,8 @@
         </p:nvSpPr>
         <p:spPr>
           <a:xfrm>
-            <a:off x="502920" y="3136392"/>
-            <a:ext cx="1325880" cy="1408176"/>
+            <a:off x="502920" y="3259927"/>
+            <a:ext cx="1325880" cy="845820"/>
           </a:xfrm>
           <a:prstGeom prst="rect">
             <a:avLst/>
@@ -24637,8 +24637,8 @@
         </p:nvSpPr>
         <p:spPr>
           <a:xfrm>
-            <a:off x="1920240" y="3136392"/>
-            <a:ext cx="3874185" cy="1408176"/>
+            <a:off x="1920240" y="3259927"/>
+            <a:ext cx="3874185" cy="845820"/>
           </a:xfrm>
           <a:prstGeom prst="rect">
             <a:avLst/>
@@ -24676,8 +24676,8 @@
         </p:nvSpPr>
         <p:spPr>
           <a:xfrm>
-            <a:off x="6023025" y="3136392"/>
-            <a:ext cx="5665750" cy="1408176"/>
+            <a:off x="6023025" y="3259927"/>
+            <a:ext cx="5665750" cy="845820"/>
           </a:xfrm>
           <a:prstGeom prst="rect">
             <a:avLst/>
@@ -24715,7 +24715,7 @@
         </p:nvCxnSpPr>
         <p:spPr>
           <a:xfrm>
-            <a:off x="502920" y="4649724"/>
+            <a:off x="502920" y="4210903"/>
             <a:ext cx="11185855" cy="0"/>
           </a:xfrm>
           <a:prstGeom prst="line">
@@ -24736,8 +24736,8 @@
         </p:nvSpPr>
         <p:spPr>
           <a:xfrm>
-            <a:off x="502920" y="4754880"/>
-            <a:ext cx="1325880" cy="1408176"/>
+            <a:off x="502920" y="4316059"/>
+            <a:ext cx="1325880" cy="704088"/>
           </a:xfrm>
           <a:prstGeom prst="rect">
             <a:avLst/>
@@ -24775,8 +24775,8 @@
         </p:nvSpPr>
         <p:spPr>
           <a:xfrm>
-            <a:off x="1920240" y="4754880"/>
-            <a:ext cx="3874185" cy="1408176"/>
+            <a:off x="1920240" y="4316059"/>
+            <a:ext cx="3874185" cy="704088"/>
           </a:xfrm>
           <a:prstGeom prst="rect">
             <a:avLst/>
@@ -24814,8 +24814,8 @@
         </p:nvSpPr>
         <p:spPr>
           <a:xfrm>
-            <a:off x="6023025" y="4754880"/>
-            <a:ext cx="5665750" cy="1408176"/>
+            <a:off x="6023025" y="4316059"/>
+            <a:ext cx="5665750" cy="704088"/>
           </a:xfrm>
           <a:prstGeom prst="rect">
             <a:avLst/>
@@ -24845,6 +24845,48 @@
           </a:p>
         </p:txBody>
       </p:sp>
+      <p:cxnSp>
+        <p:nvCxnSpPr>
+          <p:cNvPr id="17" name="cpe|statements|line|16"/>
+          <p:cNvCxnSpPr/>
+          <p:nvPr/>
+        </p:nvCxnSpPr>
+        <p:spPr>
+          <a:xfrm>
+            <a:off x="502920" y="2240371"/>
+            <a:ext cx="11185855" cy="0"/>
+          </a:xfrm>
+          <a:prstGeom prst="line">
+            <a:avLst/>
+          </a:prstGeom>
+          <a:ln w="9525">
+            <a:solidFill>
+              <a:srgbClr val="B6C0CB"/>
+            </a:solidFill>
+          </a:ln>
+        </p:spPr>
+      </p:cxnSp>
+      <p:cxnSp>
+        <p:nvCxnSpPr>
+          <p:cNvPr id="18" name="cpe|statements|line|17"/>
+          <p:cNvCxnSpPr/>
+          <p:nvPr/>
+        </p:nvCxnSpPr>
+        <p:spPr>
+          <a:xfrm>
+            <a:off x="502920" y="4988143"/>
+            <a:ext cx="11185855" cy="0"/>
+          </a:xfrm>
+          <a:prstGeom prst="line">
+            <a:avLst/>
+          </a:prstGeom>
+          <a:ln w="6350">
+            <a:solidFill>
+              <a:srgbClr val="E3E8ED"/>
+            </a:solidFill>
+          </a:ln>
+        </p:spPr>
+      </p:cxnSp>
     </p:spTree>
   </p:cSld>
   <p:clrMapOvr>

</xml_diff>